<commit_message>
Timing excludes slides the user deleted
</commit_message>
<xml_diff>
--- a/01_FULL_DECK/ADBS_FULL_answer_key.pptx
+++ b/01_FULL_DECK/ADBS_FULL_answer_key.pptx
@@ -2346,7 +2346,7 @@
           <a:p/>
           <a:p>
             <a:r>
-              <a:t>(Whole part: 292 words, about 2 min 15 s at a calm 130 words a minute. Limit: 3 minutes.)</a:t>
+              <a:t>(Whole part: 250 words, about 1 min 55 s at a calm 130 words a minute. Limit: 3 minutes.)</a:t>
             </a:r>
           </a:p>
         </p:txBody>
@@ -20249,7 +20249,7 @@
                 </a:solidFill>
                 <a:latin typeface="Arial"/>
               </a:rPr>
-              <a:t>14 slides · about 2 min 15 s</a:t>
+              <a:t>14 slides · about 1 min 55 s</a:t>
             </a:r>
           </a:p>
         </p:txBody>

</xml_diff>

<commit_message>
Bebop-style part dividers: flat colour blocks measured from the uploaded opening (contrast-checked); reference teardown saved
</commit_message>
<xml_diff>
--- a/01_FULL_DECK/ADBS_FULL_answer_key.pptx
+++ b/01_FULL_DECK/ADBS_FULL_answer_key.pptx
@@ -14193,14 +14193,190 @@
       <p:grpSpPr/>
       <p:sp>
         <p:nvSpPr>
-          <p:cNvPr id="2" name="TextBox 1"/>
+          <p:cNvPr id="2" name="Rectangle 1"/>
+          <p:cNvSpPr/>
+          <p:nvPr/>
+        </p:nvSpPr>
+        <p:spPr>
+          <a:xfrm>
+            <a:off x="0" y="0"/>
+            <a:ext cx="3657600" cy="6858000"/>
+          </a:xfrm>
+          <a:prstGeom prst="rect">
+            <a:avLst/>
+          </a:prstGeom>
+          <a:solidFill>
+            <a:srgbClr val="222C5E"/>
+          </a:solidFill>
+          <a:ln>
+            <a:noFill/>
+          </a:ln>
+          <a:effectLst/>
+        </p:spPr>
+        <p:style>
+          <a:lnRef idx="1">
+            <a:schemeClr val="accent1"/>
+          </a:lnRef>
+          <a:fillRef idx="3">
+            <a:schemeClr val="accent1"/>
+          </a:fillRef>
+          <a:effectRef idx="2">
+            <a:schemeClr val="accent1"/>
+          </a:effectRef>
+          <a:fontRef idx="minor">
+            <a:schemeClr val="lt1"/>
+          </a:fontRef>
+        </p:style>
+        <p:txBody>
+          <a:bodyPr rtlCol="0" anchor="ctr"/>
+          <a:lstStyle/>
+          <a:p>
+            <a:pPr algn="ctr"/>
+          </a:p>
+        </p:txBody>
+      </p:sp>
+      <p:sp>
+        <p:nvSpPr>
+          <p:cNvPr id="3" name="Rectangle 2"/>
+          <p:cNvSpPr/>
+          <p:nvPr/>
+        </p:nvSpPr>
+        <p:spPr>
+          <a:xfrm>
+            <a:off x="3657600" y="0"/>
+            <a:ext cx="146304" cy="6858000"/>
+          </a:xfrm>
+          <a:prstGeom prst="rect">
+            <a:avLst/>
+          </a:prstGeom>
+          <a:solidFill>
+            <a:srgbClr val="E1D8DE"/>
+          </a:solidFill>
+          <a:ln>
+            <a:noFill/>
+          </a:ln>
+          <a:effectLst/>
+        </p:spPr>
+        <p:style>
+          <a:lnRef idx="1">
+            <a:schemeClr val="accent1"/>
+          </a:lnRef>
+          <a:fillRef idx="3">
+            <a:schemeClr val="accent1"/>
+          </a:fillRef>
+          <a:effectRef idx="2">
+            <a:schemeClr val="accent1"/>
+          </a:effectRef>
+          <a:fontRef idx="minor">
+            <a:schemeClr val="lt1"/>
+          </a:fontRef>
+        </p:style>
+        <p:txBody>
+          <a:bodyPr rtlCol="0" anchor="ctr"/>
+          <a:lstStyle/>
+          <a:p>
+            <a:pPr algn="ctr"/>
+          </a:p>
+        </p:txBody>
+      </p:sp>
+      <p:sp>
+        <p:nvSpPr>
+          <p:cNvPr id="4" name="Rectangle 3"/>
+          <p:cNvSpPr/>
+          <p:nvPr/>
+        </p:nvSpPr>
+        <p:spPr>
+          <a:xfrm>
+            <a:off x="3803904" y="5989320"/>
+            <a:ext cx="8387791" cy="201168"/>
+          </a:xfrm>
+          <a:prstGeom prst="rect">
+            <a:avLst/>
+          </a:prstGeom>
+          <a:solidFill>
+            <a:srgbClr val="4C7F8C"/>
+          </a:solidFill>
+          <a:ln>
+            <a:noFill/>
+          </a:ln>
+          <a:effectLst/>
+        </p:spPr>
+        <p:style>
+          <a:lnRef idx="1">
+            <a:schemeClr val="accent1"/>
+          </a:lnRef>
+          <a:fillRef idx="3">
+            <a:schemeClr val="accent1"/>
+          </a:fillRef>
+          <a:effectRef idx="2">
+            <a:schemeClr val="accent1"/>
+          </a:effectRef>
+          <a:fontRef idx="minor">
+            <a:schemeClr val="lt1"/>
+          </a:fontRef>
+        </p:style>
+        <p:txBody>
+          <a:bodyPr rtlCol="0" anchor="ctr"/>
+          <a:lstStyle/>
+          <a:p>
+            <a:pPr algn="ctr"/>
+          </a:p>
+        </p:txBody>
+      </p:sp>
+      <p:sp>
+        <p:nvSpPr>
+          <p:cNvPr id="5" name="Rectangle 4"/>
+          <p:cNvSpPr/>
+          <p:nvPr/>
+        </p:nvSpPr>
+        <p:spPr>
+          <a:xfrm>
+            <a:off x="3803904" y="6190488"/>
+            <a:ext cx="8387791" cy="54864"/>
+          </a:xfrm>
+          <a:prstGeom prst="rect">
+            <a:avLst/>
+          </a:prstGeom>
+          <a:solidFill>
+            <a:srgbClr val="E1D8DE"/>
+          </a:solidFill>
+          <a:ln>
+            <a:noFill/>
+          </a:ln>
+          <a:effectLst/>
+        </p:spPr>
+        <p:style>
+          <a:lnRef idx="1">
+            <a:schemeClr val="accent1"/>
+          </a:lnRef>
+          <a:fillRef idx="3">
+            <a:schemeClr val="accent1"/>
+          </a:fillRef>
+          <a:effectRef idx="2">
+            <a:schemeClr val="accent1"/>
+          </a:effectRef>
+          <a:fontRef idx="minor">
+            <a:schemeClr val="lt1"/>
+          </a:fontRef>
+        </p:style>
+        <p:txBody>
+          <a:bodyPr rtlCol="0" anchor="ctr"/>
+          <a:lstStyle/>
+          <a:p>
+            <a:pPr algn="ctr"/>
+          </a:p>
+        </p:txBody>
+      </p:sp>
+      <p:sp>
+        <p:nvSpPr>
+          <p:cNvPr id="6" name="TextBox 5"/>
           <p:cNvSpPr txBox="1"/>
           <p:nvPr/>
         </p:nvSpPr>
         <p:spPr>
           <a:xfrm>
-            <a:off x="411480" y="914400"/>
-            <a:ext cx="3291840" cy="2743200"/>
+            <a:off x="320040" y="320040"/>
+            <a:ext cx="3108960" cy="457200"/>
           </a:xfrm>
           <a:prstGeom prst="rect">
             <a:avLst/>
@@ -14219,9 +14395,48 @@
               </a:lnSpc>
             </a:pPr>
             <a:r>
-              <a:rPr sz="18000" b="1">
-                <a:solidFill>
-                  <a:srgbClr val="F2B27A"/>
+              <a:rPr sz="2800" b="1">
+                <a:solidFill>
+                  <a:srgbClr val="FFFFFF"/>
+                </a:solidFill>
+                <a:latin typeface="Arial"/>
+              </a:rPr>
+              <a:t>PART</a:t>
+            </a:r>
+          </a:p>
+        </p:txBody>
+      </p:sp>
+      <p:sp>
+        <p:nvSpPr>
+          <p:cNvPr id="7" name="TextBox 6"/>
+          <p:cNvSpPr txBox="1"/>
+          <p:nvPr/>
+        </p:nvSpPr>
+        <p:spPr>
+          <a:xfrm>
+            <a:off x="182880" y="731520"/>
+            <a:ext cx="3383280" cy="3108960"/>
+          </a:xfrm>
+          <a:prstGeom prst="rect">
+            <a:avLst/>
+          </a:prstGeom>
+          <a:noFill/>
+        </p:spPr>
+        <p:txBody>
+          <a:bodyPr wrap="square" anchor="t" lIns="0" rIns="0" tIns="0" bIns="0">
+            <a:spAutoFit/>
+          </a:bodyPr>
+          <a:lstStyle/>
+          <a:p>
+            <a:pPr algn="l">
+              <a:lnSpc>
+                <a:spcPct val="100000"/>
+              </a:lnSpc>
+            </a:pPr>
+            <a:r>
+              <a:rPr sz="22000" b="1">
+                <a:solidFill>
+                  <a:srgbClr val="FFFFFF"/>
                 </a:solidFill>
                 <a:latin typeface="Arial"/>
               </a:rPr>
@@ -14232,14 +14447,14 @@
       </p:sp>
       <p:sp>
         <p:nvSpPr>
-          <p:cNvPr id="3" name="TextBox 2"/>
+          <p:cNvPr id="8" name="TextBox 7"/>
           <p:cNvSpPr txBox="1"/>
           <p:nvPr/>
         </p:nvSpPr>
         <p:spPr>
           <a:xfrm>
-            <a:off x="3840480" y="548640"/>
-            <a:ext cx="7863840" cy="2103120"/>
+            <a:off x="4206240" y="502920"/>
+            <a:ext cx="7589520" cy="2103120"/>
           </a:xfrm>
           <a:prstGeom prst="rect">
             <a:avLst/>
@@ -14271,14 +14486,14 @@
       </p:sp>
       <p:sp>
         <p:nvSpPr>
-          <p:cNvPr id="4" name="TextBox 3"/>
+          <p:cNvPr id="9" name="TextBox 8"/>
           <p:cNvSpPr txBox="1"/>
           <p:nvPr/>
         </p:nvSpPr>
         <p:spPr>
           <a:xfrm>
-            <a:off x="3840480" y="2743200"/>
-            <a:ext cx="7863840" cy="914400"/>
+            <a:off x="4206240" y="2697480"/>
+            <a:ext cx="7589520" cy="914400"/>
           </a:xfrm>
           <a:prstGeom prst="rect">
             <a:avLst/>
@@ -14310,14 +14525,14 @@
       </p:sp>
       <p:sp>
         <p:nvSpPr>
-          <p:cNvPr id="5" name="TextBox 4"/>
+          <p:cNvPr id="10" name="TextBox 9"/>
           <p:cNvSpPr txBox="1"/>
           <p:nvPr/>
         </p:nvSpPr>
         <p:spPr>
           <a:xfrm>
-            <a:off x="3840480" y="3794760"/>
-            <a:ext cx="7863840" cy="1005840"/>
+            <a:off x="4206240" y="3703320"/>
+            <a:ext cx="7589520" cy="1005840"/>
           </a:xfrm>
           <a:prstGeom prst="rect">
             <a:avLst/>
@@ -14349,14 +14564,14 @@
       </p:sp>
       <p:sp>
         <p:nvSpPr>
-          <p:cNvPr id="6" name="EXEMPT_PROGRESS"/>
+          <p:cNvPr id="11" name="EXEMPT_PROGRESS"/>
           <p:cNvSpPr txBox="1"/>
           <p:nvPr/>
         </p:nvSpPr>
         <p:spPr>
           <a:xfrm>
-            <a:off x="3840480" y="5074920"/>
-            <a:ext cx="7863840" cy="457200"/>
+            <a:off x="4206240" y="4983480"/>
+            <a:ext cx="7589520" cy="457200"/>
           </a:xfrm>
           <a:prstGeom prst="rect">
             <a:avLst/>
@@ -20673,14 +20888,190 @@
       <p:grpSpPr/>
       <p:sp>
         <p:nvSpPr>
-          <p:cNvPr id="2" name="TextBox 1"/>
+          <p:cNvPr id="2" name="Rectangle 1"/>
+          <p:cNvSpPr/>
+          <p:nvPr/>
+        </p:nvSpPr>
+        <p:spPr>
+          <a:xfrm>
+            <a:off x="0" y="0"/>
+            <a:ext cx="3657600" cy="6858000"/>
+          </a:xfrm>
+          <a:prstGeom prst="rect">
+            <a:avLst/>
+          </a:prstGeom>
+          <a:solidFill>
+            <a:srgbClr val="951C1D"/>
+          </a:solidFill>
+          <a:ln>
+            <a:noFill/>
+          </a:ln>
+          <a:effectLst/>
+        </p:spPr>
+        <p:style>
+          <a:lnRef idx="1">
+            <a:schemeClr val="accent1"/>
+          </a:lnRef>
+          <a:fillRef idx="3">
+            <a:schemeClr val="accent1"/>
+          </a:fillRef>
+          <a:effectRef idx="2">
+            <a:schemeClr val="accent1"/>
+          </a:effectRef>
+          <a:fontRef idx="minor">
+            <a:schemeClr val="lt1"/>
+          </a:fontRef>
+        </p:style>
+        <p:txBody>
+          <a:bodyPr rtlCol="0" anchor="ctr"/>
+          <a:lstStyle/>
+          <a:p>
+            <a:pPr algn="ctr"/>
+          </a:p>
+        </p:txBody>
+      </p:sp>
+      <p:sp>
+        <p:nvSpPr>
+          <p:cNvPr id="3" name="Rectangle 2"/>
+          <p:cNvSpPr/>
+          <p:nvPr/>
+        </p:nvSpPr>
+        <p:spPr>
+          <a:xfrm>
+            <a:off x="3657600" y="0"/>
+            <a:ext cx="146304" cy="6858000"/>
+          </a:xfrm>
+          <a:prstGeom prst="rect">
+            <a:avLst/>
+          </a:prstGeom>
+          <a:solidFill>
+            <a:srgbClr val="E1D8DE"/>
+          </a:solidFill>
+          <a:ln>
+            <a:noFill/>
+          </a:ln>
+          <a:effectLst/>
+        </p:spPr>
+        <p:style>
+          <a:lnRef idx="1">
+            <a:schemeClr val="accent1"/>
+          </a:lnRef>
+          <a:fillRef idx="3">
+            <a:schemeClr val="accent1"/>
+          </a:fillRef>
+          <a:effectRef idx="2">
+            <a:schemeClr val="accent1"/>
+          </a:effectRef>
+          <a:fontRef idx="minor">
+            <a:schemeClr val="lt1"/>
+          </a:fontRef>
+        </p:style>
+        <p:txBody>
+          <a:bodyPr rtlCol="0" anchor="ctr"/>
+          <a:lstStyle/>
+          <a:p>
+            <a:pPr algn="ctr"/>
+          </a:p>
+        </p:txBody>
+      </p:sp>
+      <p:sp>
+        <p:nvSpPr>
+          <p:cNvPr id="4" name="Rectangle 3"/>
+          <p:cNvSpPr/>
+          <p:nvPr/>
+        </p:nvSpPr>
+        <p:spPr>
+          <a:xfrm>
+            <a:off x="3803904" y="5989320"/>
+            <a:ext cx="8387791" cy="201168"/>
+          </a:xfrm>
+          <a:prstGeom prst="rect">
+            <a:avLst/>
+          </a:prstGeom>
+          <a:solidFill>
+            <a:srgbClr val="4C7F8C"/>
+          </a:solidFill>
+          <a:ln>
+            <a:noFill/>
+          </a:ln>
+          <a:effectLst/>
+        </p:spPr>
+        <p:style>
+          <a:lnRef idx="1">
+            <a:schemeClr val="accent1"/>
+          </a:lnRef>
+          <a:fillRef idx="3">
+            <a:schemeClr val="accent1"/>
+          </a:fillRef>
+          <a:effectRef idx="2">
+            <a:schemeClr val="accent1"/>
+          </a:effectRef>
+          <a:fontRef idx="minor">
+            <a:schemeClr val="lt1"/>
+          </a:fontRef>
+        </p:style>
+        <p:txBody>
+          <a:bodyPr rtlCol="0" anchor="ctr"/>
+          <a:lstStyle/>
+          <a:p>
+            <a:pPr algn="ctr"/>
+          </a:p>
+        </p:txBody>
+      </p:sp>
+      <p:sp>
+        <p:nvSpPr>
+          <p:cNvPr id="5" name="Rectangle 4"/>
+          <p:cNvSpPr/>
+          <p:nvPr/>
+        </p:nvSpPr>
+        <p:spPr>
+          <a:xfrm>
+            <a:off x="3803904" y="6190488"/>
+            <a:ext cx="8387791" cy="54864"/>
+          </a:xfrm>
+          <a:prstGeom prst="rect">
+            <a:avLst/>
+          </a:prstGeom>
+          <a:solidFill>
+            <a:srgbClr val="E1D8DE"/>
+          </a:solidFill>
+          <a:ln>
+            <a:noFill/>
+          </a:ln>
+          <a:effectLst/>
+        </p:spPr>
+        <p:style>
+          <a:lnRef idx="1">
+            <a:schemeClr val="accent1"/>
+          </a:lnRef>
+          <a:fillRef idx="3">
+            <a:schemeClr val="accent1"/>
+          </a:fillRef>
+          <a:effectRef idx="2">
+            <a:schemeClr val="accent1"/>
+          </a:effectRef>
+          <a:fontRef idx="minor">
+            <a:schemeClr val="lt1"/>
+          </a:fontRef>
+        </p:style>
+        <p:txBody>
+          <a:bodyPr rtlCol="0" anchor="ctr"/>
+          <a:lstStyle/>
+          <a:p>
+            <a:pPr algn="ctr"/>
+          </a:p>
+        </p:txBody>
+      </p:sp>
+      <p:sp>
+        <p:nvSpPr>
+          <p:cNvPr id="6" name="TextBox 5"/>
           <p:cNvSpPr txBox="1"/>
           <p:nvPr/>
         </p:nvSpPr>
         <p:spPr>
           <a:xfrm>
-            <a:off x="411480" y="914400"/>
-            <a:ext cx="3291840" cy="2743200"/>
+            <a:off x="320040" y="320040"/>
+            <a:ext cx="3108960" cy="457200"/>
           </a:xfrm>
           <a:prstGeom prst="rect">
             <a:avLst/>
@@ -20699,9 +21090,48 @@
               </a:lnSpc>
             </a:pPr>
             <a:r>
-              <a:rPr sz="18000" b="1">
-                <a:solidFill>
-                  <a:srgbClr val="F2B27A"/>
+              <a:rPr sz="2800" b="1">
+                <a:solidFill>
+                  <a:srgbClr val="FFFFFF"/>
+                </a:solidFill>
+                <a:latin typeface="Arial"/>
+              </a:rPr>
+              <a:t>PART</a:t>
+            </a:r>
+          </a:p>
+        </p:txBody>
+      </p:sp>
+      <p:sp>
+        <p:nvSpPr>
+          <p:cNvPr id="7" name="TextBox 6"/>
+          <p:cNvSpPr txBox="1"/>
+          <p:nvPr/>
+        </p:nvSpPr>
+        <p:spPr>
+          <a:xfrm>
+            <a:off x="182880" y="731520"/>
+            <a:ext cx="3383280" cy="3108960"/>
+          </a:xfrm>
+          <a:prstGeom prst="rect">
+            <a:avLst/>
+          </a:prstGeom>
+          <a:noFill/>
+        </p:spPr>
+        <p:txBody>
+          <a:bodyPr wrap="square" anchor="t" lIns="0" rIns="0" tIns="0" bIns="0">
+            <a:spAutoFit/>
+          </a:bodyPr>
+          <a:lstStyle/>
+          <a:p>
+            <a:pPr algn="l">
+              <a:lnSpc>
+                <a:spcPct val="100000"/>
+              </a:lnSpc>
+            </a:pPr>
+            <a:r>
+              <a:rPr sz="22000" b="1">
+                <a:solidFill>
+                  <a:srgbClr val="FFFFFF"/>
                 </a:solidFill>
                 <a:latin typeface="Arial"/>
               </a:rPr>
@@ -20712,14 +21142,14 @@
       </p:sp>
       <p:sp>
         <p:nvSpPr>
-          <p:cNvPr id="3" name="TextBox 2"/>
+          <p:cNvPr id="8" name="TextBox 7"/>
           <p:cNvSpPr txBox="1"/>
           <p:nvPr/>
         </p:nvSpPr>
         <p:spPr>
           <a:xfrm>
-            <a:off x="3840480" y="548640"/>
-            <a:ext cx="7863840" cy="2103120"/>
+            <a:off x="4206240" y="502920"/>
+            <a:ext cx="7589520" cy="2103120"/>
           </a:xfrm>
           <a:prstGeom prst="rect">
             <a:avLst/>
@@ -20751,14 +21181,14 @@
       </p:sp>
       <p:sp>
         <p:nvSpPr>
-          <p:cNvPr id="4" name="TextBox 3"/>
+          <p:cNvPr id="9" name="TextBox 8"/>
           <p:cNvSpPr txBox="1"/>
           <p:nvPr/>
         </p:nvSpPr>
         <p:spPr>
           <a:xfrm>
-            <a:off x="3840480" y="2743200"/>
-            <a:ext cx="7863840" cy="914400"/>
+            <a:off x="4206240" y="2697480"/>
+            <a:ext cx="7589520" cy="914400"/>
           </a:xfrm>
           <a:prstGeom prst="rect">
             <a:avLst/>
@@ -20790,14 +21220,14 @@
       </p:sp>
       <p:sp>
         <p:nvSpPr>
-          <p:cNvPr id="5" name="TextBox 4"/>
+          <p:cNvPr id="10" name="TextBox 9"/>
           <p:cNvSpPr txBox="1"/>
           <p:nvPr/>
         </p:nvSpPr>
         <p:spPr>
           <a:xfrm>
-            <a:off x="3840480" y="3794760"/>
-            <a:ext cx="7863840" cy="1005840"/>
+            <a:off x="4206240" y="3703320"/>
+            <a:ext cx="7589520" cy="1005840"/>
           </a:xfrm>
           <a:prstGeom prst="rect">
             <a:avLst/>
@@ -20829,14 +21259,14 @@
       </p:sp>
       <p:sp>
         <p:nvSpPr>
-          <p:cNvPr id="6" name="EXEMPT_PROGRESS"/>
+          <p:cNvPr id="11" name="EXEMPT_PROGRESS"/>
           <p:cNvSpPr txBox="1"/>
           <p:nvPr/>
         </p:nvSpPr>
         <p:spPr>
           <a:xfrm>
-            <a:off x="3840480" y="5074920"/>
-            <a:ext cx="7863840" cy="457200"/>
+            <a:off x="4206240" y="4983480"/>
+            <a:ext cx="7589520" cy="457200"/>
           </a:xfrm>
           <a:prstGeom prst="rect">
             <a:avLst/>
@@ -24845,14 +25275,190 @@
       <p:grpSpPr/>
       <p:sp>
         <p:nvSpPr>
-          <p:cNvPr id="2" name="TextBox 1"/>
+          <p:cNvPr id="2" name="Rectangle 1"/>
+          <p:cNvSpPr/>
+          <p:nvPr/>
+        </p:nvSpPr>
+        <p:spPr>
+          <a:xfrm>
+            <a:off x="0" y="0"/>
+            <a:ext cx="3657600" cy="6858000"/>
+          </a:xfrm>
+          <a:prstGeom prst="rect">
+            <a:avLst/>
+          </a:prstGeom>
+          <a:solidFill>
+            <a:srgbClr val="AF9510"/>
+          </a:solidFill>
+          <a:ln>
+            <a:noFill/>
+          </a:ln>
+          <a:effectLst/>
+        </p:spPr>
+        <p:style>
+          <a:lnRef idx="1">
+            <a:schemeClr val="accent1"/>
+          </a:lnRef>
+          <a:fillRef idx="3">
+            <a:schemeClr val="accent1"/>
+          </a:fillRef>
+          <a:effectRef idx="2">
+            <a:schemeClr val="accent1"/>
+          </a:effectRef>
+          <a:fontRef idx="minor">
+            <a:schemeClr val="lt1"/>
+          </a:fontRef>
+        </p:style>
+        <p:txBody>
+          <a:bodyPr rtlCol="0" anchor="ctr"/>
+          <a:lstStyle/>
+          <a:p>
+            <a:pPr algn="ctr"/>
+          </a:p>
+        </p:txBody>
+      </p:sp>
+      <p:sp>
+        <p:nvSpPr>
+          <p:cNvPr id="3" name="Rectangle 2"/>
+          <p:cNvSpPr/>
+          <p:nvPr/>
+        </p:nvSpPr>
+        <p:spPr>
+          <a:xfrm>
+            <a:off x="3657600" y="0"/>
+            <a:ext cx="146304" cy="6858000"/>
+          </a:xfrm>
+          <a:prstGeom prst="rect">
+            <a:avLst/>
+          </a:prstGeom>
+          <a:solidFill>
+            <a:srgbClr val="E1D8DE"/>
+          </a:solidFill>
+          <a:ln>
+            <a:noFill/>
+          </a:ln>
+          <a:effectLst/>
+        </p:spPr>
+        <p:style>
+          <a:lnRef idx="1">
+            <a:schemeClr val="accent1"/>
+          </a:lnRef>
+          <a:fillRef idx="3">
+            <a:schemeClr val="accent1"/>
+          </a:fillRef>
+          <a:effectRef idx="2">
+            <a:schemeClr val="accent1"/>
+          </a:effectRef>
+          <a:fontRef idx="minor">
+            <a:schemeClr val="lt1"/>
+          </a:fontRef>
+        </p:style>
+        <p:txBody>
+          <a:bodyPr rtlCol="0" anchor="ctr"/>
+          <a:lstStyle/>
+          <a:p>
+            <a:pPr algn="ctr"/>
+          </a:p>
+        </p:txBody>
+      </p:sp>
+      <p:sp>
+        <p:nvSpPr>
+          <p:cNvPr id="4" name="Rectangle 3"/>
+          <p:cNvSpPr/>
+          <p:nvPr/>
+        </p:nvSpPr>
+        <p:spPr>
+          <a:xfrm>
+            <a:off x="3803904" y="5989320"/>
+            <a:ext cx="8387791" cy="201168"/>
+          </a:xfrm>
+          <a:prstGeom prst="rect">
+            <a:avLst/>
+          </a:prstGeom>
+          <a:solidFill>
+            <a:srgbClr val="4C7F8C"/>
+          </a:solidFill>
+          <a:ln>
+            <a:noFill/>
+          </a:ln>
+          <a:effectLst/>
+        </p:spPr>
+        <p:style>
+          <a:lnRef idx="1">
+            <a:schemeClr val="accent1"/>
+          </a:lnRef>
+          <a:fillRef idx="3">
+            <a:schemeClr val="accent1"/>
+          </a:fillRef>
+          <a:effectRef idx="2">
+            <a:schemeClr val="accent1"/>
+          </a:effectRef>
+          <a:fontRef idx="minor">
+            <a:schemeClr val="lt1"/>
+          </a:fontRef>
+        </p:style>
+        <p:txBody>
+          <a:bodyPr rtlCol="0" anchor="ctr"/>
+          <a:lstStyle/>
+          <a:p>
+            <a:pPr algn="ctr"/>
+          </a:p>
+        </p:txBody>
+      </p:sp>
+      <p:sp>
+        <p:nvSpPr>
+          <p:cNvPr id="5" name="Rectangle 4"/>
+          <p:cNvSpPr/>
+          <p:nvPr/>
+        </p:nvSpPr>
+        <p:spPr>
+          <a:xfrm>
+            <a:off x="3803904" y="6190488"/>
+            <a:ext cx="8387791" cy="54864"/>
+          </a:xfrm>
+          <a:prstGeom prst="rect">
+            <a:avLst/>
+          </a:prstGeom>
+          <a:solidFill>
+            <a:srgbClr val="E1D8DE"/>
+          </a:solidFill>
+          <a:ln>
+            <a:noFill/>
+          </a:ln>
+          <a:effectLst/>
+        </p:spPr>
+        <p:style>
+          <a:lnRef idx="1">
+            <a:schemeClr val="accent1"/>
+          </a:lnRef>
+          <a:fillRef idx="3">
+            <a:schemeClr val="accent1"/>
+          </a:fillRef>
+          <a:effectRef idx="2">
+            <a:schemeClr val="accent1"/>
+          </a:effectRef>
+          <a:fontRef idx="minor">
+            <a:schemeClr val="lt1"/>
+          </a:fontRef>
+        </p:style>
+        <p:txBody>
+          <a:bodyPr rtlCol="0" anchor="ctr"/>
+          <a:lstStyle/>
+          <a:p>
+            <a:pPr algn="ctr"/>
+          </a:p>
+        </p:txBody>
+      </p:sp>
+      <p:sp>
+        <p:nvSpPr>
+          <p:cNvPr id="6" name="TextBox 5"/>
           <p:cNvSpPr txBox="1"/>
           <p:nvPr/>
         </p:nvSpPr>
         <p:spPr>
           <a:xfrm>
-            <a:off x="411480" y="914400"/>
-            <a:ext cx="3291840" cy="2743200"/>
+            <a:off x="320040" y="320040"/>
+            <a:ext cx="3108960" cy="457200"/>
           </a:xfrm>
           <a:prstGeom prst="rect">
             <a:avLst/>
@@ -24871,9 +25477,48 @@
               </a:lnSpc>
             </a:pPr>
             <a:r>
-              <a:rPr sz="18000" b="1">
-                <a:solidFill>
-                  <a:srgbClr val="F2B27A"/>
+              <a:rPr sz="2800" b="1">
+                <a:solidFill>
+                  <a:srgbClr val="14202E"/>
+                </a:solidFill>
+                <a:latin typeface="Arial"/>
+              </a:rPr>
+              <a:t>PART</a:t>
+            </a:r>
+          </a:p>
+        </p:txBody>
+      </p:sp>
+      <p:sp>
+        <p:nvSpPr>
+          <p:cNvPr id="7" name="TextBox 6"/>
+          <p:cNvSpPr txBox="1"/>
+          <p:nvPr/>
+        </p:nvSpPr>
+        <p:spPr>
+          <a:xfrm>
+            <a:off x="182880" y="731520"/>
+            <a:ext cx="3383280" cy="3108960"/>
+          </a:xfrm>
+          <a:prstGeom prst="rect">
+            <a:avLst/>
+          </a:prstGeom>
+          <a:noFill/>
+        </p:spPr>
+        <p:txBody>
+          <a:bodyPr wrap="square" anchor="t" lIns="0" rIns="0" tIns="0" bIns="0">
+            <a:spAutoFit/>
+          </a:bodyPr>
+          <a:lstStyle/>
+          <a:p>
+            <a:pPr algn="l">
+              <a:lnSpc>
+                <a:spcPct val="100000"/>
+              </a:lnSpc>
+            </a:pPr>
+            <a:r>
+              <a:rPr sz="22000" b="1">
+                <a:solidFill>
+                  <a:srgbClr val="14202E"/>
                 </a:solidFill>
                 <a:latin typeface="Arial"/>
               </a:rPr>
@@ -24884,14 +25529,14 @@
       </p:sp>
       <p:sp>
         <p:nvSpPr>
-          <p:cNvPr id="3" name="TextBox 2"/>
+          <p:cNvPr id="8" name="TextBox 7"/>
           <p:cNvSpPr txBox="1"/>
           <p:nvPr/>
         </p:nvSpPr>
         <p:spPr>
           <a:xfrm>
-            <a:off x="3840480" y="548640"/>
-            <a:ext cx="7863840" cy="2103120"/>
+            <a:off x="4206240" y="502920"/>
+            <a:ext cx="7589520" cy="2103120"/>
           </a:xfrm>
           <a:prstGeom prst="rect">
             <a:avLst/>
@@ -24923,14 +25568,14 @@
       </p:sp>
       <p:sp>
         <p:nvSpPr>
-          <p:cNvPr id="4" name="TextBox 3"/>
+          <p:cNvPr id="9" name="TextBox 8"/>
           <p:cNvSpPr txBox="1"/>
           <p:nvPr/>
         </p:nvSpPr>
         <p:spPr>
           <a:xfrm>
-            <a:off x="3840480" y="2743200"/>
-            <a:ext cx="7863840" cy="914400"/>
+            <a:off x="4206240" y="2697480"/>
+            <a:ext cx="7589520" cy="914400"/>
           </a:xfrm>
           <a:prstGeom prst="rect">
             <a:avLst/>
@@ -24962,14 +25607,14 @@
       </p:sp>
       <p:sp>
         <p:nvSpPr>
-          <p:cNvPr id="5" name="TextBox 4"/>
+          <p:cNvPr id="10" name="TextBox 9"/>
           <p:cNvSpPr txBox="1"/>
           <p:nvPr/>
         </p:nvSpPr>
         <p:spPr>
           <a:xfrm>
-            <a:off x="3840480" y="3794760"/>
-            <a:ext cx="7863840" cy="1005840"/>
+            <a:off x="4206240" y="3703320"/>
+            <a:ext cx="7589520" cy="1005840"/>
           </a:xfrm>
           <a:prstGeom prst="rect">
             <a:avLst/>
@@ -25001,14 +25646,14 @@
       </p:sp>
       <p:sp>
         <p:nvSpPr>
-          <p:cNvPr id="6" name="EXEMPT_PROGRESS"/>
+          <p:cNvPr id="11" name="EXEMPT_PROGRESS"/>
           <p:cNvSpPr txBox="1"/>
           <p:nvPr/>
         </p:nvSpPr>
         <p:spPr>
           <a:xfrm>
-            <a:off x="3840480" y="5074920"/>
-            <a:ext cx="7863840" cy="457200"/>
+            <a:off x="4206240" y="4983480"/>
+            <a:ext cx="7589520" cy="457200"/>
           </a:xfrm>
           <a:prstGeom prst="rect">
             <a:avLst/>
@@ -28478,14 +29123,190 @@
       <p:grpSpPr/>
       <p:sp>
         <p:nvSpPr>
-          <p:cNvPr id="2" name="TextBox 1"/>
+          <p:cNvPr id="2" name="Rectangle 1"/>
+          <p:cNvSpPr/>
+          <p:nvPr/>
+        </p:nvSpPr>
+        <p:spPr>
+          <a:xfrm>
+            <a:off x="0" y="0"/>
+            <a:ext cx="3657600" cy="6858000"/>
+          </a:xfrm>
+          <a:prstGeom prst="rect">
+            <a:avLst/>
+          </a:prstGeom>
+          <a:solidFill>
+            <a:srgbClr val="951C1D"/>
+          </a:solidFill>
+          <a:ln>
+            <a:noFill/>
+          </a:ln>
+          <a:effectLst/>
+        </p:spPr>
+        <p:style>
+          <a:lnRef idx="1">
+            <a:schemeClr val="accent1"/>
+          </a:lnRef>
+          <a:fillRef idx="3">
+            <a:schemeClr val="accent1"/>
+          </a:fillRef>
+          <a:effectRef idx="2">
+            <a:schemeClr val="accent1"/>
+          </a:effectRef>
+          <a:fontRef idx="minor">
+            <a:schemeClr val="lt1"/>
+          </a:fontRef>
+        </p:style>
+        <p:txBody>
+          <a:bodyPr rtlCol="0" anchor="ctr"/>
+          <a:lstStyle/>
+          <a:p>
+            <a:pPr algn="ctr"/>
+          </a:p>
+        </p:txBody>
+      </p:sp>
+      <p:sp>
+        <p:nvSpPr>
+          <p:cNvPr id="3" name="Rectangle 2"/>
+          <p:cNvSpPr/>
+          <p:nvPr/>
+        </p:nvSpPr>
+        <p:spPr>
+          <a:xfrm>
+            <a:off x="3657600" y="0"/>
+            <a:ext cx="146304" cy="6858000"/>
+          </a:xfrm>
+          <a:prstGeom prst="rect">
+            <a:avLst/>
+          </a:prstGeom>
+          <a:solidFill>
+            <a:srgbClr val="E1D8DE"/>
+          </a:solidFill>
+          <a:ln>
+            <a:noFill/>
+          </a:ln>
+          <a:effectLst/>
+        </p:spPr>
+        <p:style>
+          <a:lnRef idx="1">
+            <a:schemeClr val="accent1"/>
+          </a:lnRef>
+          <a:fillRef idx="3">
+            <a:schemeClr val="accent1"/>
+          </a:fillRef>
+          <a:effectRef idx="2">
+            <a:schemeClr val="accent1"/>
+          </a:effectRef>
+          <a:fontRef idx="minor">
+            <a:schemeClr val="lt1"/>
+          </a:fontRef>
+        </p:style>
+        <p:txBody>
+          <a:bodyPr rtlCol="0" anchor="ctr"/>
+          <a:lstStyle/>
+          <a:p>
+            <a:pPr algn="ctr"/>
+          </a:p>
+        </p:txBody>
+      </p:sp>
+      <p:sp>
+        <p:nvSpPr>
+          <p:cNvPr id="4" name="Rectangle 3"/>
+          <p:cNvSpPr/>
+          <p:nvPr/>
+        </p:nvSpPr>
+        <p:spPr>
+          <a:xfrm>
+            <a:off x="3803904" y="5989320"/>
+            <a:ext cx="8387791" cy="201168"/>
+          </a:xfrm>
+          <a:prstGeom prst="rect">
+            <a:avLst/>
+          </a:prstGeom>
+          <a:solidFill>
+            <a:srgbClr val="4C7F8C"/>
+          </a:solidFill>
+          <a:ln>
+            <a:noFill/>
+          </a:ln>
+          <a:effectLst/>
+        </p:spPr>
+        <p:style>
+          <a:lnRef idx="1">
+            <a:schemeClr val="accent1"/>
+          </a:lnRef>
+          <a:fillRef idx="3">
+            <a:schemeClr val="accent1"/>
+          </a:fillRef>
+          <a:effectRef idx="2">
+            <a:schemeClr val="accent1"/>
+          </a:effectRef>
+          <a:fontRef idx="minor">
+            <a:schemeClr val="lt1"/>
+          </a:fontRef>
+        </p:style>
+        <p:txBody>
+          <a:bodyPr rtlCol="0" anchor="ctr"/>
+          <a:lstStyle/>
+          <a:p>
+            <a:pPr algn="ctr"/>
+          </a:p>
+        </p:txBody>
+      </p:sp>
+      <p:sp>
+        <p:nvSpPr>
+          <p:cNvPr id="5" name="Rectangle 4"/>
+          <p:cNvSpPr/>
+          <p:nvPr/>
+        </p:nvSpPr>
+        <p:spPr>
+          <a:xfrm>
+            <a:off x="3803904" y="6190488"/>
+            <a:ext cx="8387791" cy="54864"/>
+          </a:xfrm>
+          <a:prstGeom prst="rect">
+            <a:avLst/>
+          </a:prstGeom>
+          <a:solidFill>
+            <a:srgbClr val="E1D8DE"/>
+          </a:solidFill>
+          <a:ln>
+            <a:noFill/>
+          </a:ln>
+          <a:effectLst/>
+        </p:spPr>
+        <p:style>
+          <a:lnRef idx="1">
+            <a:schemeClr val="accent1"/>
+          </a:lnRef>
+          <a:fillRef idx="3">
+            <a:schemeClr val="accent1"/>
+          </a:fillRef>
+          <a:effectRef idx="2">
+            <a:schemeClr val="accent1"/>
+          </a:effectRef>
+          <a:fontRef idx="minor">
+            <a:schemeClr val="lt1"/>
+          </a:fontRef>
+        </p:style>
+        <p:txBody>
+          <a:bodyPr rtlCol="0" anchor="ctr"/>
+          <a:lstStyle/>
+          <a:p>
+            <a:pPr algn="ctr"/>
+          </a:p>
+        </p:txBody>
+      </p:sp>
+      <p:sp>
+        <p:nvSpPr>
+          <p:cNvPr id="6" name="TextBox 5"/>
           <p:cNvSpPr txBox="1"/>
           <p:nvPr/>
         </p:nvSpPr>
         <p:spPr>
           <a:xfrm>
-            <a:off x="411480" y="914400"/>
-            <a:ext cx="3291840" cy="2743200"/>
+            <a:off x="320040" y="320040"/>
+            <a:ext cx="3108960" cy="457200"/>
           </a:xfrm>
           <a:prstGeom prst="rect">
             <a:avLst/>
@@ -28504,9 +29325,48 @@
               </a:lnSpc>
             </a:pPr>
             <a:r>
-              <a:rPr sz="18000" b="1">
-                <a:solidFill>
-                  <a:srgbClr val="F2B27A"/>
+              <a:rPr sz="2800" b="1">
+                <a:solidFill>
+                  <a:srgbClr val="FFFFFF"/>
+                </a:solidFill>
+                <a:latin typeface="Arial"/>
+              </a:rPr>
+              <a:t>PART</a:t>
+            </a:r>
+          </a:p>
+        </p:txBody>
+      </p:sp>
+      <p:sp>
+        <p:nvSpPr>
+          <p:cNvPr id="7" name="TextBox 6"/>
+          <p:cNvSpPr txBox="1"/>
+          <p:nvPr/>
+        </p:nvSpPr>
+        <p:spPr>
+          <a:xfrm>
+            <a:off x="182880" y="731520"/>
+            <a:ext cx="3383280" cy="3108960"/>
+          </a:xfrm>
+          <a:prstGeom prst="rect">
+            <a:avLst/>
+          </a:prstGeom>
+          <a:noFill/>
+        </p:spPr>
+        <p:txBody>
+          <a:bodyPr wrap="square" anchor="t" lIns="0" rIns="0" tIns="0" bIns="0">
+            <a:spAutoFit/>
+          </a:bodyPr>
+          <a:lstStyle/>
+          <a:p>
+            <a:pPr algn="l">
+              <a:lnSpc>
+                <a:spcPct val="100000"/>
+              </a:lnSpc>
+            </a:pPr>
+            <a:r>
+              <a:rPr sz="22000" b="1">
+                <a:solidFill>
+                  <a:srgbClr val="FFFFFF"/>
                 </a:solidFill>
                 <a:latin typeface="Arial"/>
               </a:rPr>
@@ -28517,14 +29377,14 @@
       </p:sp>
       <p:sp>
         <p:nvSpPr>
-          <p:cNvPr id="3" name="TextBox 2"/>
+          <p:cNvPr id="8" name="TextBox 7"/>
           <p:cNvSpPr txBox="1"/>
           <p:nvPr/>
         </p:nvSpPr>
         <p:spPr>
           <a:xfrm>
-            <a:off x="3840480" y="548640"/>
-            <a:ext cx="7863840" cy="2103120"/>
+            <a:off x="4206240" y="502920"/>
+            <a:ext cx="7589520" cy="2103120"/>
           </a:xfrm>
           <a:prstGeom prst="rect">
             <a:avLst/>
@@ -28556,14 +29416,14 @@
       </p:sp>
       <p:sp>
         <p:nvSpPr>
-          <p:cNvPr id="4" name="TextBox 3"/>
+          <p:cNvPr id="9" name="TextBox 8"/>
           <p:cNvSpPr txBox="1"/>
           <p:nvPr/>
         </p:nvSpPr>
         <p:spPr>
           <a:xfrm>
-            <a:off x="3840480" y="2743200"/>
-            <a:ext cx="7863840" cy="914400"/>
+            <a:off x="4206240" y="2697480"/>
+            <a:ext cx="7589520" cy="914400"/>
           </a:xfrm>
           <a:prstGeom prst="rect">
             <a:avLst/>
@@ -28595,14 +29455,14 @@
       </p:sp>
       <p:sp>
         <p:nvSpPr>
-          <p:cNvPr id="5" name="TextBox 4"/>
+          <p:cNvPr id="10" name="TextBox 9"/>
           <p:cNvSpPr txBox="1"/>
           <p:nvPr/>
         </p:nvSpPr>
         <p:spPr>
           <a:xfrm>
-            <a:off x="3840480" y="3794760"/>
-            <a:ext cx="7863840" cy="1005840"/>
+            <a:off x="4206240" y="3703320"/>
+            <a:ext cx="7589520" cy="1005840"/>
           </a:xfrm>
           <a:prstGeom prst="rect">
             <a:avLst/>
@@ -28634,14 +29494,14 @@
       </p:sp>
       <p:sp>
         <p:nvSpPr>
-          <p:cNvPr id="6" name="EXEMPT_PROGRESS"/>
+          <p:cNvPr id="11" name="EXEMPT_PROGRESS"/>
           <p:cNvSpPr txBox="1"/>
           <p:nvPr/>
         </p:nvSpPr>
         <p:spPr>
           <a:xfrm>
-            <a:off x="3840480" y="5074920"/>
-            <a:ext cx="7863840" cy="457200"/>
+            <a:off x="4206240" y="4983480"/>
+            <a:ext cx="7589520" cy="457200"/>
           </a:xfrm>
           <a:prstGeom prst="rect">
             <a:avLst/>
@@ -31579,14 +32439,190 @@
       <p:grpSpPr/>
       <p:sp>
         <p:nvSpPr>
-          <p:cNvPr id="2" name="TextBox 1"/>
+          <p:cNvPr id="2" name="Rectangle 1"/>
+          <p:cNvSpPr/>
+          <p:nvPr/>
+        </p:nvSpPr>
+        <p:spPr>
+          <a:xfrm>
+            <a:off x="0" y="0"/>
+            <a:ext cx="3657600" cy="6858000"/>
+          </a:xfrm>
+          <a:prstGeom prst="rect">
+            <a:avLst/>
+          </a:prstGeom>
+          <a:solidFill>
+            <a:srgbClr val="222C5E"/>
+          </a:solidFill>
+          <a:ln>
+            <a:noFill/>
+          </a:ln>
+          <a:effectLst/>
+        </p:spPr>
+        <p:style>
+          <a:lnRef idx="1">
+            <a:schemeClr val="accent1"/>
+          </a:lnRef>
+          <a:fillRef idx="3">
+            <a:schemeClr val="accent1"/>
+          </a:fillRef>
+          <a:effectRef idx="2">
+            <a:schemeClr val="accent1"/>
+          </a:effectRef>
+          <a:fontRef idx="minor">
+            <a:schemeClr val="lt1"/>
+          </a:fontRef>
+        </p:style>
+        <p:txBody>
+          <a:bodyPr rtlCol="0" anchor="ctr"/>
+          <a:lstStyle/>
+          <a:p>
+            <a:pPr algn="ctr"/>
+          </a:p>
+        </p:txBody>
+      </p:sp>
+      <p:sp>
+        <p:nvSpPr>
+          <p:cNvPr id="3" name="Rectangle 2"/>
+          <p:cNvSpPr/>
+          <p:nvPr/>
+        </p:nvSpPr>
+        <p:spPr>
+          <a:xfrm>
+            <a:off x="3657600" y="0"/>
+            <a:ext cx="146304" cy="6858000"/>
+          </a:xfrm>
+          <a:prstGeom prst="rect">
+            <a:avLst/>
+          </a:prstGeom>
+          <a:solidFill>
+            <a:srgbClr val="E1D8DE"/>
+          </a:solidFill>
+          <a:ln>
+            <a:noFill/>
+          </a:ln>
+          <a:effectLst/>
+        </p:spPr>
+        <p:style>
+          <a:lnRef idx="1">
+            <a:schemeClr val="accent1"/>
+          </a:lnRef>
+          <a:fillRef idx="3">
+            <a:schemeClr val="accent1"/>
+          </a:fillRef>
+          <a:effectRef idx="2">
+            <a:schemeClr val="accent1"/>
+          </a:effectRef>
+          <a:fontRef idx="minor">
+            <a:schemeClr val="lt1"/>
+          </a:fontRef>
+        </p:style>
+        <p:txBody>
+          <a:bodyPr rtlCol="0" anchor="ctr"/>
+          <a:lstStyle/>
+          <a:p>
+            <a:pPr algn="ctr"/>
+          </a:p>
+        </p:txBody>
+      </p:sp>
+      <p:sp>
+        <p:nvSpPr>
+          <p:cNvPr id="4" name="Rectangle 3"/>
+          <p:cNvSpPr/>
+          <p:nvPr/>
+        </p:nvSpPr>
+        <p:spPr>
+          <a:xfrm>
+            <a:off x="3803904" y="5989320"/>
+            <a:ext cx="8387791" cy="201168"/>
+          </a:xfrm>
+          <a:prstGeom prst="rect">
+            <a:avLst/>
+          </a:prstGeom>
+          <a:solidFill>
+            <a:srgbClr val="4C7F8C"/>
+          </a:solidFill>
+          <a:ln>
+            <a:noFill/>
+          </a:ln>
+          <a:effectLst/>
+        </p:spPr>
+        <p:style>
+          <a:lnRef idx="1">
+            <a:schemeClr val="accent1"/>
+          </a:lnRef>
+          <a:fillRef idx="3">
+            <a:schemeClr val="accent1"/>
+          </a:fillRef>
+          <a:effectRef idx="2">
+            <a:schemeClr val="accent1"/>
+          </a:effectRef>
+          <a:fontRef idx="minor">
+            <a:schemeClr val="lt1"/>
+          </a:fontRef>
+        </p:style>
+        <p:txBody>
+          <a:bodyPr rtlCol="0" anchor="ctr"/>
+          <a:lstStyle/>
+          <a:p>
+            <a:pPr algn="ctr"/>
+          </a:p>
+        </p:txBody>
+      </p:sp>
+      <p:sp>
+        <p:nvSpPr>
+          <p:cNvPr id="5" name="Rectangle 4"/>
+          <p:cNvSpPr/>
+          <p:nvPr/>
+        </p:nvSpPr>
+        <p:spPr>
+          <a:xfrm>
+            <a:off x="3803904" y="6190488"/>
+            <a:ext cx="8387791" cy="54864"/>
+          </a:xfrm>
+          <a:prstGeom prst="rect">
+            <a:avLst/>
+          </a:prstGeom>
+          <a:solidFill>
+            <a:srgbClr val="E1D8DE"/>
+          </a:solidFill>
+          <a:ln>
+            <a:noFill/>
+          </a:ln>
+          <a:effectLst/>
+        </p:spPr>
+        <p:style>
+          <a:lnRef idx="1">
+            <a:schemeClr val="accent1"/>
+          </a:lnRef>
+          <a:fillRef idx="3">
+            <a:schemeClr val="accent1"/>
+          </a:fillRef>
+          <a:effectRef idx="2">
+            <a:schemeClr val="accent1"/>
+          </a:effectRef>
+          <a:fontRef idx="minor">
+            <a:schemeClr val="lt1"/>
+          </a:fontRef>
+        </p:style>
+        <p:txBody>
+          <a:bodyPr rtlCol="0" anchor="ctr"/>
+          <a:lstStyle/>
+          <a:p>
+            <a:pPr algn="ctr"/>
+          </a:p>
+        </p:txBody>
+      </p:sp>
+      <p:sp>
+        <p:nvSpPr>
+          <p:cNvPr id="6" name="TextBox 5"/>
           <p:cNvSpPr txBox="1"/>
           <p:nvPr/>
         </p:nvSpPr>
         <p:spPr>
           <a:xfrm>
-            <a:off x="411480" y="914400"/>
-            <a:ext cx="3291840" cy="2743200"/>
+            <a:off x="320040" y="320040"/>
+            <a:ext cx="3108960" cy="457200"/>
           </a:xfrm>
           <a:prstGeom prst="rect">
             <a:avLst/>
@@ -31605,9 +32641,48 @@
               </a:lnSpc>
             </a:pPr>
             <a:r>
-              <a:rPr sz="18000" b="1">
-                <a:solidFill>
-                  <a:srgbClr val="F2B27A"/>
+              <a:rPr sz="2800" b="1">
+                <a:solidFill>
+                  <a:srgbClr val="FFFFFF"/>
+                </a:solidFill>
+                <a:latin typeface="Arial"/>
+              </a:rPr>
+              <a:t>PART</a:t>
+            </a:r>
+          </a:p>
+        </p:txBody>
+      </p:sp>
+      <p:sp>
+        <p:nvSpPr>
+          <p:cNvPr id="7" name="TextBox 6"/>
+          <p:cNvSpPr txBox="1"/>
+          <p:nvPr/>
+        </p:nvSpPr>
+        <p:spPr>
+          <a:xfrm>
+            <a:off x="182880" y="731520"/>
+            <a:ext cx="3383280" cy="3108960"/>
+          </a:xfrm>
+          <a:prstGeom prst="rect">
+            <a:avLst/>
+          </a:prstGeom>
+          <a:noFill/>
+        </p:spPr>
+        <p:txBody>
+          <a:bodyPr wrap="square" anchor="t" lIns="0" rIns="0" tIns="0" bIns="0">
+            <a:spAutoFit/>
+          </a:bodyPr>
+          <a:lstStyle/>
+          <a:p>
+            <a:pPr algn="l">
+              <a:lnSpc>
+                <a:spcPct val="100000"/>
+              </a:lnSpc>
+            </a:pPr>
+            <a:r>
+              <a:rPr sz="22000" b="1">
+                <a:solidFill>
+                  <a:srgbClr val="FFFFFF"/>
                 </a:solidFill>
                 <a:latin typeface="Arial"/>
               </a:rPr>
@@ -31618,14 +32693,14 @@
       </p:sp>
       <p:sp>
         <p:nvSpPr>
-          <p:cNvPr id="3" name="TextBox 2"/>
+          <p:cNvPr id="8" name="TextBox 7"/>
           <p:cNvSpPr txBox="1"/>
           <p:nvPr/>
         </p:nvSpPr>
         <p:spPr>
           <a:xfrm>
-            <a:off x="3840480" y="548640"/>
-            <a:ext cx="7863840" cy="2103120"/>
+            <a:off x="4206240" y="502920"/>
+            <a:ext cx="7589520" cy="2103120"/>
           </a:xfrm>
           <a:prstGeom prst="rect">
             <a:avLst/>
@@ -31657,14 +32732,14 @@
       </p:sp>
       <p:sp>
         <p:nvSpPr>
-          <p:cNvPr id="4" name="TextBox 3"/>
+          <p:cNvPr id="9" name="TextBox 8"/>
           <p:cNvSpPr txBox="1"/>
           <p:nvPr/>
         </p:nvSpPr>
         <p:spPr>
           <a:xfrm>
-            <a:off x="3840480" y="2743200"/>
-            <a:ext cx="7863840" cy="914400"/>
+            <a:off x="4206240" y="2697480"/>
+            <a:ext cx="7589520" cy="914400"/>
           </a:xfrm>
           <a:prstGeom prst="rect">
             <a:avLst/>
@@ -31696,14 +32771,14 @@
       </p:sp>
       <p:sp>
         <p:nvSpPr>
-          <p:cNvPr id="5" name="TextBox 4"/>
+          <p:cNvPr id="10" name="TextBox 9"/>
           <p:cNvSpPr txBox="1"/>
           <p:nvPr/>
         </p:nvSpPr>
         <p:spPr>
           <a:xfrm>
-            <a:off x="3840480" y="3794760"/>
-            <a:ext cx="7863840" cy="1005840"/>
+            <a:off x="4206240" y="3703320"/>
+            <a:ext cx="7589520" cy="1005840"/>
           </a:xfrm>
           <a:prstGeom prst="rect">
             <a:avLst/>
@@ -31735,14 +32810,14 @@
       </p:sp>
       <p:sp>
         <p:nvSpPr>
-          <p:cNvPr id="6" name="EXEMPT_PROGRESS"/>
+          <p:cNvPr id="11" name="EXEMPT_PROGRESS"/>
           <p:cNvSpPr txBox="1"/>
           <p:nvPr/>
         </p:nvSpPr>
         <p:spPr>
           <a:xfrm>
-            <a:off x="3840480" y="5074920"/>
-            <a:ext cx="7863840" cy="457200"/>
+            <a:off x="4206240" y="4983480"/>
+            <a:ext cx="7589520" cy="457200"/>
           </a:xfrm>
           <a:prstGeom prst="rect">
             <a:avLst/>
@@ -34635,14 +35710,190 @@
       <p:grpSpPr/>
       <p:sp>
         <p:nvSpPr>
-          <p:cNvPr id="2" name="TextBox 1"/>
+          <p:cNvPr id="2" name="Rectangle 1"/>
+          <p:cNvSpPr/>
+          <p:nvPr/>
+        </p:nvSpPr>
+        <p:spPr>
+          <a:xfrm>
+            <a:off x="0" y="0"/>
+            <a:ext cx="3657600" cy="6858000"/>
+          </a:xfrm>
+          <a:prstGeom prst="rect">
+            <a:avLst/>
+          </a:prstGeom>
+          <a:solidFill>
+            <a:srgbClr val="AF9510"/>
+          </a:solidFill>
+          <a:ln>
+            <a:noFill/>
+          </a:ln>
+          <a:effectLst/>
+        </p:spPr>
+        <p:style>
+          <a:lnRef idx="1">
+            <a:schemeClr val="accent1"/>
+          </a:lnRef>
+          <a:fillRef idx="3">
+            <a:schemeClr val="accent1"/>
+          </a:fillRef>
+          <a:effectRef idx="2">
+            <a:schemeClr val="accent1"/>
+          </a:effectRef>
+          <a:fontRef idx="minor">
+            <a:schemeClr val="lt1"/>
+          </a:fontRef>
+        </p:style>
+        <p:txBody>
+          <a:bodyPr rtlCol="0" anchor="ctr"/>
+          <a:lstStyle/>
+          <a:p>
+            <a:pPr algn="ctr"/>
+          </a:p>
+        </p:txBody>
+      </p:sp>
+      <p:sp>
+        <p:nvSpPr>
+          <p:cNvPr id="3" name="Rectangle 2"/>
+          <p:cNvSpPr/>
+          <p:nvPr/>
+        </p:nvSpPr>
+        <p:spPr>
+          <a:xfrm>
+            <a:off x="3657600" y="0"/>
+            <a:ext cx="146304" cy="6858000"/>
+          </a:xfrm>
+          <a:prstGeom prst="rect">
+            <a:avLst/>
+          </a:prstGeom>
+          <a:solidFill>
+            <a:srgbClr val="E1D8DE"/>
+          </a:solidFill>
+          <a:ln>
+            <a:noFill/>
+          </a:ln>
+          <a:effectLst/>
+        </p:spPr>
+        <p:style>
+          <a:lnRef idx="1">
+            <a:schemeClr val="accent1"/>
+          </a:lnRef>
+          <a:fillRef idx="3">
+            <a:schemeClr val="accent1"/>
+          </a:fillRef>
+          <a:effectRef idx="2">
+            <a:schemeClr val="accent1"/>
+          </a:effectRef>
+          <a:fontRef idx="minor">
+            <a:schemeClr val="lt1"/>
+          </a:fontRef>
+        </p:style>
+        <p:txBody>
+          <a:bodyPr rtlCol="0" anchor="ctr"/>
+          <a:lstStyle/>
+          <a:p>
+            <a:pPr algn="ctr"/>
+          </a:p>
+        </p:txBody>
+      </p:sp>
+      <p:sp>
+        <p:nvSpPr>
+          <p:cNvPr id="4" name="Rectangle 3"/>
+          <p:cNvSpPr/>
+          <p:nvPr/>
+        </p:nvSpPr>
+        <p:spPr>
+          <a:xfrm>
+            <a:off x="3803904" y="5989320"/>
+            <a:ext cx="8387791" cy="201168"/>
+          </a:xfrm>
+          <a:prstGeom prst="rect">
+            <a:avLst/>
+          </a:prstGeom>
+          <a:solidFill>
+            <a:srgbClr val="4C7F8C"/>
+          </a:solidFill>
+          <a:ln>
+            <a:noFill/>
+          </a:ln>
+          <a:effectLst/>
+        </p:spPr>
+        <p:style>
+          <a:lnRef idx="1">
+            <a:schemeClr val="accent1"/>
+          </a:lnRef>
+          <a:fillRef idx="3">
+            <a:schemeClr val="accent1"/>
+          </a:fillRef>
+          <a:effectRef idx="2">
+            <a:schemeClr val="accent1"/>
+          </a:effectRef>
+          <a:fontRef idx="minor">
+            <a:schemeClr val="lt1"/>
+          </a:fontRef>
+        </p:style>
+        <p:txBody>
+          <a:bodyPr rtlCol="0" anchor="ctr"/>
+          <a:lstStyle/>
+          <a:p>
+            <a:pPr algn="ctr"/>
+          </a:p>
+        </p:txBody>
+      </p:sp>
+      <p:sp>
+        <p:nvSpPr>
+          <p:cNvPr id="5" name="Rectangle 4"/>
+          <p:cNvSpPr/>
+          <p:nvPr/>
+        </p:nvSpPr>
+        <p:spPr>
+          <a:xfrm>
+            <a:off x="3803904" y="6190488"/>
+            <a:ext cx="8387791" cy="54864"/>
+          </a:xfrm>
+          <a:prstGeom prst="rect">
+            <a:avLst/>
+          </a:prstGeom>
+          <a:solidFill>
+            <a:srgbClr val="E1D8DE"/>
+          </a:solidFill>
+          <a:ln>
+            <a:noFill/>
+          </a:ln>
+          <a:effectLst/>
+        </p:spPr>
+        <p:style>
+          <a:lnRef idx="1">
+            <a:schemeClr val="accent1"/>
+          </a:lnRef>
+          <a:fillRef idx="3">
+            <a:schemeClr val="accent1"/>
+          </a:fillRef>
+          <a:effectRef idx="2">
+            <a:schemeClr val="accent1"/>
+          </a:effectRef>
+          <a:fontRef idx="minor">
+            <a:schemeClr val="lt1"/>
+          </a:fontRef>
+        </p:style>
+        <p:txBody>
+          <a:bodyPr rtlCol="0" anchor="ctr"/>
+          <a:lstStyle/>
+          <a:p>
+            <a:pPr algn="ctr"/>
+          </a:p>
+        </p:txBody>
+      </p:sp>
+      <p:sp>
+        <p:nvSpPr>
+          <p:cNvPr id="6" name="TextBox 5"/>
           <p:cNvSpPr txBox="1"/>
           <p:nvPr/>
         </p:nvSpPr>
         <p:spPr>
           <a:xfrm>
-            <a:off x="411480" y="914400"/>
-            <a:ext cx="3291840" cy="2743200"/>
+            <a:off x="320040" y="320040"/>
+            <a:ext cx="3108960" cy="457200"/>
           </a:xfrm>
           <a:prstGeom prst="rect">
             <a:avLst/>
@@ -34661,9 +35912,48 @@
               </a:lnSpc>
             </a:pPr>
             <a:r>
-              <a:rPr sz="18000" b="1">
-                <a:solidFill>
-                  <a:srgbClr val="F2B27A"/>
+              <a:rPr sz="2800" b="1">
+                <a:solidFill>
+                  <a:srgbClr val="14202E"/>
+                </a:solidFill>
+                <a:latin typeface="Arial"/>
+              </a:rPr>
+              <a:t>PART</a:t>
+            </a:r>
+          </a:p>
+        </p:txBody>
+      </p:sp>
+      <p:sp>
+        <p:nvSpPr>
+          <p:cNvPr id="7" name="TextBox 6"/>
+          <p:cNvSpPr txBox="1"/>
+          <p:nvPr/>
+        </p:nvSpPr>
+        <p:spPr>
+          <a:xfrm>
+            <a:off x="182880" y="731520"/>
+            <a:ext cx="3383280" cy="3108960"/>
+          </a:xfrm>
+          <a:prstGeom prst="rect">
+            <a:avLst/>
+          </a:prstGeom>
+          <a:noFill/>
+        </p:spPr>
+        <p:txBody>
+          <a:bodyPr wrap="square" anchor="t" lIns="0" rIns="0" tIns="0" bIns="0">
+            <a:spAutoFit/>
+          </a:bodyPr>
+          <a:lstStyle/>
+          <a:p>
+            <a:pPr algn="l">
+              <a:lnSpc>
+                <a:spcPct val="100000"/>
+              </a:lnSpc>
+            </a:pPr>
+            <a:r>
+              <a:rPr sz="22000" b="1">
+                <a:solidFill>
+                  <a:srgbClr val="14202E"/>
                 </a:solidFill>
                 <a:latin typeface="Arial"/>
               </a:rPr>
@@ -34674,14 +35964,14 @@
       </p:sp>
       <p:sp>
         <p:nvSpPr>
-          <p:cNvPr id="3" name="TextBox 2"/>
+          <p:cNvPr id="8" name="TextBox 7"/>
           <p:cNvSpPr txBox="1"/>
           <p:nvPr/>
         </p:nvSpPr>
         <p:spPr>
           <a:xfrm>
-            <a:off x="3840480" y="548640"/>
-            <a:ext cx="7863840" cy="2103120"/>
+            <a:off x="4206240" y="502920"/>
+            <a:ext cx="7589520" cy="2103120"/>
           </a:xfrm>
           <a:prstGeom prst="rect">
             <a:avLst/>
@@ -34713,14 +36003,14 @@
       </p:sp>
       <p:sp>
         <p:nvSpPr>
-          <p:cNvPr id="4" name="TextBox 3"/>
+          <p:cNvPr id="9" name="TextBox 8"/>
           <p:cNvSpPr txBox="1"/>
           <p:nvPr/>
         </p:nvSpPr>
         <p:spPr>
           <a:xfrm>
-            <a:off x="3840480" y="2743200"/>
-            <a:ext cx="7863840" cy="914400"/>
+            <a:off x="4206240" y="2697480"/>
+            <a:ext cx="7589520" cy="914400"/>
           </a:xfrm>
           <a:prstGeom prst="rect">
             <a:avLst/>
@@ -34752,14 +36042,14 @@
       </p:sp>
       <p:sp>
         <p:nvSpPr>
-          <p:cNvPr id="5" name="TextBox 4"/>
+          <p:cNvPr id="10" name="TextBox 9"/>
           <p:cNvSpPr txBox="1"/>
           <p:nvPr/>
         </p:nvSpPr>
         <p:spPr>
           <a:xfrm>
-            <a:off x="3840480" y="3794760"/>
-            <a:ext cx="7863840" cy="1005840"/>
+            <a:off x="4206240" y="3703320"/>
+            <a:ext cx="7589520" cy="1005840"/>
           </a:xfrm>
           <a:prstGeom prst="rect">
             <a:avLst/>
@@ -34791,14 +36081,14 @@
       </p:sp>
       <p:sp>
         <p:nvSpPr>
-          <p:cNvPr id="6" name="EXEMPT_PROGRESS"/>
+          <p:cNvPr id="11" name="EXEMPT_PROGRESS"/>
           <p:cNvSpPr txBox="1"/>
           <p:nvPr/>
         </p:nvSpPr>
         <p:spPr>
           <a:xfrm>
-            <a:off x="3840480" y="5074920"/>
-            <a:ext cx="7863840" cy="457200"/>
+            <a:off x="4206240" y="4983480"/>
+            <a:ext cx="7589520" cy="457200"/>
           </a:xfrm>
           <a:prstGeom prst="rect">
             <a:avLst/>
@@ -37358,14 +38648,190 @@
       <p:grpSpPr/>
       <p:sp>
         <p:nvSpPr>
-          <p:cNvPr id="2" name="TextBox 1"/>
+          <p:cNvPr id="2" name="Rectangle 1"/>
+          <p:cNvSpPr/>
+          <p:nvPr/>
+        </p:nvSpPr>
+        <p:spPr>
+          <a:xfrm>
+            <a:off x="0" y="0"/>
+            <a:ext cx="3657600" cy="6858000"/>
+          </a:xfrm>
+          <a:prstGeom prst="rect">
+            <a:avLst/>
+          </a:prstGeom>
+          <a:solidFill>
+            <a:srgbClr val="951C1D"/>
+          </a:solidFill>
+          <a:ln>
+            <a:noFill/>
+          </a:ln>
+          <a:effectLst/>
+        </p:spPr>
+        <p:style>
+          <a:lnRef idx="1">
+            <a:schemeClr val="accent1"/>
+          </a:lnRef>
+          <a:fillRef idx="3">
+            <a:schemeClr val="accent1"/>
+          </a:fillRef>
+          <a:effectRef idx="2">
+            <a:schemeClr val="accent1"/>
+          </a:effectRef>
+          <a:fontRef idx="minor">
+            <a:schemeClr val="lt1"/>
+          </a:fontRef>
+        </p:style>
+        <p:txBody>
+          <a:bodyPr rtlCol="0" anchor="ctr"/>
+          <a:lstStyle/>
+          <a:p>
+            <a:pPr algn="ctr"/>
+          </a:p>
+        </p:txBody>
+      </p:sp>
+      <p:sp>
+        <p:nvSpPr>
+          <p:cNvPr id="3" name="Rectangle 2"/>
+          <p:cNvSpPr/>
+          <p:nvPr/>
+        </p:nvSpPr>
+        <p:spPr>
+          <a:xfrm>
+            <a:off x="3657600" y="0"/>
+            <a:ext cx="146304" cy="6858000"/>
+          </a:xfrm>
+          <a:prstGeom prst="rect">
+            <a:avLst/>
+          </a:prstGeom>
+          <a:solidFill>
+            <a:srgbClr val="E1D8DE"/>
+          </a:solidFill>
+          <a:ln>
+            <a:noFill/>
+          </a:ln>
+          <a:effectLst/>
+        </p:spPr>
+        <p:style>
+          <a:lnRef idx="1">
+            <a:schemeClr val="accent1"/>
+          </a:lnRef>
+          <a:fillRef idx="3">
+            <a:schemeClr val="accent1"/>
+          </a:fillRef>
+          <a:effectRef idx="2">
+            <a:schemeClr val="accent1"/>
+          </a:effectRef>
+          <a:fontRef idx="minor">
+            <a:schemeClr val="lt1"/>
+          </a:fontRef>
+        </p:style>
+        <p:txBody>
+          <a:bodyPr rtlCol="0" anchor="ctr"/>
+          <a:lstStyle/>
+          <a:p>
+            <a:pPr algn="ctr"/>
+          </a:p>
+        </p:txBody>
+      </p:sp>
+      <p:sp>
+        <p:nvSpPr>
+          <p:cNvPr id="4" name="Rectangle 3"/>
+          <p:cNvSpPr/>
+          <p:nvPr/>
+        </p:nvSpPr>
+        <p:spPr>
+          <a:xfrm>
+            <a:off x="3803904" y="5989320"/>
+            <a:ext cx="8387791" cy="201168"/>
+          </a:xfrm>
+          <a:prstGeom prst="rect">
+            <a:avLst/>
+          </a:prstGeom>
+          <a:solidFill>
+            <a:srgbClr val="4C7F8C"/>
+          </a:solidFill>
+          <a:ln>
+            <a:noFill/>
+          </a:ln>
+          <a:effectLst/>
+        </p:spPr>
+        <p:style>
+          <a:lnRef idx="1">
+            <a:schemeClr val="accent1"/>
+          </a:lnRef>
+          <a:fillRef idx="3">
+            <a:schemeClr val="accent1"/>
+          </a:fillRef>
+          <a:effectRef idx="2">
+            <a:schemeClr val="accent1"/>
+          </a:effectRef>
+          <a:fontRef idx="minor">
+            <a:schemeClr val="lt1"/>
+          </a:fontRef>
+        </p:style>
+        <p:txBody>
+          <a:bodyPr rtlCol="0" anchor="ctr"/>
+          <a:lstStyle/>
+          <a:p>
+            <a:pPr algn="ctr"/>
+          </a:p>
+        </p:txBody>
+      </p:sp>
+      <p:sp>
+        <p:nvSpPr>
+          <p:cNvPr id="5" name="Rectangle 4"/>
+          <p:cNvSpPr/>
+          <p:nvPr/>
+        </p:nvSpPr>
+        <p:spPr>
+          <a:xfrm>
+            <a:off x="3803904" y="6190488"/>
+            <a:ext cx="8387791" cy="54864"/>
+          </a:xfrm>
+          <a:prstGeom prst="rect">
+            <a:avLst/>
+          </a:prstGeom>
+          <a:solidFill>
+            <a:srgbClr val="E1D8DE"/>
+          </a:solidFill>
+          <a:ln>
+            <a:noFill/>
+          </a:ln>
+          <a:effectLst/>
+        </p:spPr>
+        <p:style>
+          <a:lnRef idx="1">
+            <a:schemeClr val="accent1"/>
+          </a:lnRef>
+          <a:fillRef idx="3">
+            <a:schemeClr val="accent1"/>
+          </a:fillRef>
+          <a:effectRef idx="2">
+            <a:schemeClr val="accent1"/>
+          </a:effectRef>
+          <a:fontRef idx="minor">
+            <a:schemeClr val="lt1"/>
+          </a:fontRef>
+        </p:style>
+        <p:txBody>
+          <a:bodyPr rtlCol="0" anchor="ctr"/>
+          <a:lstStyle/>
+          <a:p>
+            <a:pPr algn="ctr"/>
+          </a:p>
+        </p:txBody>
+      </p:sp>
+      <p:sp>
+        <p:nvSpPr>
+          <p:cNvPr id="6" name="TextBox 5"/>
           <p:cNvSpPr txBox="1"/>
           <p:nvPr/>
         </p:nvSpPr>
         <p:spPr>
           <a:xfrm>
-            <a:off x="411480" y="914400"/>
-            <a:ext cx="3291840" cy="2743200"/>
+            <a:off x="320040" y="320040"/>
+            <a:ext cx="3108960" cy="457200"/>
           </a:xfrm>
           <a:prstGeom prst="rect">
             <a:avLst/>
@@ -37384,9 +38850,48 @@
               </a:lnSpc>
             </a:pPr>
             <a:r>
-              <a:rPr sz="18000" b="1">
-                <a:solidFill>
-                  <a:srgbClr val="F2B27A"/>
+              <a:rPr sz="2800" b="1">
+                <a:solidFill>
+                  <a:srgbClr val="FFFFFF"/>
+                </a:solidFill>
+                <a:latin typeface="Arial"/>
+              </a:rPr>
+              <a:t>PART</a:t>
+            </a:r>
+          </a:p>
+        </p:txBody>
+      </p:sp>
+      <p:sp>
+        <p:nvSpPr>
+          <p:cNvPr id="7" name="TextBox 6"/>
+          <p:cNvSpPr txBox="1"/>
+          <p:nvPr/>
+        </p:nvSpPr>
+        <p:spPr>
+          <a:xfrm>
+            <a:off x="182880" y="731520"/>
+            <a:ext cx="3383280" cy="3108960"/>
+          </a:xfrm>
+          <a:prstGeom prst="rect">
+            <a:avLst/>
+          </a:prstGeom>
+          <a:noFill/>
+        </p:spPr>
+        <p:txBody>
+          <a:bodyPr wrap="square" anchor="t" lIns="0" rIns="0" tIns="0" bIns="0">
+            <a:spAutoFit/>
+          </a:bodyPr>
+          <a:lstStyle/>
+          <a:p>
+            <a:pPr algn="l">
+              <a:lnSpc>
+                <a:spcPct val="100000"/>
+              </a:lnSpc>
+            </a:pPr>
+            <a:r>
+              <a:rPr sz="22000" b="1">
+                <a:solidFill>
+                  <a:srgbClr val="FFFFFF"/>
                 </a:solidFill>
                 <a:latin typeface="Arial"/>
               </a:rPr>
@@ -37397,14 +38902,14 @@
       </p:sp>
       <p:sp>
         <p:nvSpPr>
-          <p:cNvPr id="3" name="TextBox 2"/>
+          <p:cNvPr id="8" name="TextBox 7"/>
           <p:cNvSpPr txBox="1"/>
           <p:nvPr/>
         </p:nvSpPr>
         <p:spPr>
           <a:xfrm>
-            <a:off x="3840480" y="548640"/>
-            <a:ext cx="7863840" cy="2103120"/>
+            <a:off x="4206240" y="502920"/>
+            <a:ext cx="7589520" cy="2103120"/>
           </a:xfrm>
           <a:prstGeom prst="rect">
             <a:avLst/>
@@ -37436,14 +38941,14 @@
       </p:sp>
       <p:sp>
         <p:nvSpPr>
-          <p:cNvPr id="4" name="TextBox 3"/>
+          <p:cNvPr id="9" name="TextBox 8"/>
           <p:cNvSpPr txBox="1"/>
           <p:nvPr/>
         </p:nvSpPr>
         <p:spPr>
           <a:xfrm>
-            <a:off x="3840480" y="2743200"/>
-            <a:ext cx="7863840" cy="914400"/>
+            <a:off x="4206240" y="2697480"/>
+            <a:ext cx="7589520" cy="914400"/>
           </a:xfrm>
           <a:prstGeom prst="rect">
             <a:avLst/>
@@ -37475,14 +38980,14 @@
       </p:sp>
       <p:sp>
         <p:nvSpPr>
-          <p:cNvPr id="5" name="TextBox 4"/>
+          <p:cNvPr id="10" name="TextBox 9"/>
           <p:cNvSpPr txBox="1"/>
           <p:nvPr/>
         </p:nvSpPr>
         <p:spPr>
           <a:xfrm>
-            <a:off x="3840480" y="3794760"/>
-            <a:ext cx="7863840" cy="1005840"/>
+            <a:off x="4206240" y="3703320"/>
+            <a:ext cx="7589520" cy="1005840"/>
           </a:xfrm>
           <a:prstGeom prst="rect">
             <a:avLst/>
@@ -37514,14 +39019,14 @@
       </p:sp>
       <p:sp>
         <p:nvSpPr>
-          <p:cNvPr id="6" name="EXEMPT_PROGRESS"/>
+          <p:cNvPr id="11" name="EXEMPT_PROGRESS"/>
           <p:cNvSpPr txBox="1"/>
           <p:nvPr/>
         </p:nvSpPr>
         <p:spPr>
           <a:xfrm>
-            <a:off x="3840480" y="5074920"/>
-            <a:ext cx="7863840" cy="457200"/>
+            <a:off x="4206240" y="4983480"/>
+            <a:ext cx="7589520" cy="457200"/>
           </a:xfrm>
           <a:prstGeom prst="rect">
             <a:avLst/>
@@ -40511,14 +42016,190 @@
       <p:grpSpPr/>
       <p:sp>
         <p:nvSpPr>
-          <p:cNvPr id="2" name="TextBox 1"/>
+          <p:cNvPr id="2" name="Rectangle 1"/>
+          <p:cNvSpPr/>
+          <p:nvPr/>
+        </p:nvSpPr>
+        <p:spPr>
+          <a:xfrm>
+            <a:off x="0" y="0"/>
+            <a:ext cx="3657600" cy="6858000"/>
+          </a:xfrm>
+          <a:prstGeom prst="rect">
+            <a:avLst/>
+          </a:prstGeom>
+          <a:solidFill>
+            <a:srgbClr val="222C5E"/>
+          </a:solidFill>
+          <a:ln>
+            <a:noFill/>
+          </a:ln>
+          <a:effectLst/>
+        </p:spPr>
+        <p:style>
+          <a:lnRef idx="1">
+            <a:schemeClr val="accent1"/>
+          </a:lnRef>
+          <a:fillRef idx="3">
+            <a:schemeClr val="accent1"/>
+          </a:fillRef>
+          <a:effectRef idx="2">
+            <a:schemeClr val="accent1"/>
+          </a:effectRef>
+          <a:fontRef idx="minor">
+            <a:schemeClr val="lt1"/>
+          </a:fontRef>
+        </p:style>
+        <p:txBody>
+          <a:bodyPr rtlCol="0" anchor="ctr"/>
+          <a:lstStyle/>
+          <a:p>
+            <a:pPr algn="ctr"/>
+          </a:p>
+        </p:txBody>
+      </p:sp>
+      <p:sp>
+        <p:nvSpPr>
+          <p:cNvPr id="3" name="Rectangle 2"/>
+          <p:cNvSpPr/>
+          <p:nvPr/>
+        </p:nvSpPr>
+        <p:spPr>
+          <a:xfrm>
+            <a:off x="3657600" y="0"/>
+            <a:ext cx="146304" cy="6858000"/>
+          </a:xfrm>
+          <a:prstGeom prst="rect">
+            <a:avLst/>
+          </a:prstGeom>
+          <a:solidFill>
+            <a:srgbClr val="E1D8DE"/>
+          </a:solidFill>
+          <a:ln>
+            <a:noFill/>
+          </a:ln>
+          <a:effectLst/>
+        </p:spPr>
+        <p:style>
+          <a:lnRef idx="1">
+            <a:schemeClr val="accent1"/>
+          </a:lnRef>
+          <a:fillRef idx="3">
+            <a:schemeClr val="accent1"/>
+          </a:fillRef>
+          <a:effectRef idx="2">
+            <a:schemeClr val="accent1"/>
+          </a:effectRef>
+          <a:fontRef idx="minor">
+            <a:schemeClr val="lt1"/>
+          </a:fontRef>
+        </p:style>
+        <p:txBody>
+          <a:bodyPr rtlCol="0" anchor="ctr"/>
+          <a:lstStyle/>
+          <a:p>
+            <a:pPr algn="ctr"/>
+          </a:p>
+        </p:txBody>
+      </p:sp>
+      <p:sp>
+        <p:nvSpPr>
+          <p:cNvPr id="4" name="Rectangle 3"/>
+          <p:cNvSpPr/>
+          <p:nvPr/>
+        </p:nvSpPr>
+        <p:spPr>
+          <a:xfrm>
+            <a:off x="3803904" y="5989320"/>
+            <a:ext cx="8387791" cy="201168"/>
+          </a:xfrm>
+          <a:prstGeom prst="rect">
+            <a:avLst/>
+          </a:prstGeom>
+          <a:solidFill>
+            <a:srgbClr val="4C7F8C"/>
+          </a:solidFill>
+          <a:ln>
+            <a:noFill/>
+          </a:ln>
+          <a:effectLst/>
+        </p:spPr>
+        <p:style>
+          <a:lnRef idx="1">
+            <a:schemeClr val="accent1"/>
+          </a:lnRef>
+          <a:fillRef idx="3">
+            <a:schemeClr val="accent1"/>
+          </a:fillRef>
+          <a:effectRef idx="2">
+            <a:schemeClr val="accent1"/>
+          </a:effectRef>
+          <a:fontRef idx="minor">
+            <a:schemeClr val="lt1"/>
+          </a:fontRef>
+        </p:style>
+        <p:txBody>
+          <a:bodyPr rtlCol="0" anchor="ctr"/>
+          <a:lstStyle/>
+          <a:p>
+            <a:pPr algn="ctr"/>
+          </a:p>
+        </p:txBody>
+      </p:sp>
+      <p:sp>
+        <p:nvSpPr>
+          <p:cNvPr id="5" name="Rectangle 4"/>
+          <p:cNvSpPr/>
+          <p:nvPr/>
+        </p:nvSpPr>
+        <p:spPr>
+          <a:xfrm>
+            <a:off x="3803904" y="6190488"/>
+            <a:ext cx="8387791" cy="54864"/>
+          </a:xfrm>
+          <a:prstGeom prst="rect">
+            <a:avLst/>
+          </a:prstGeom>
+          <a:solidFill>
+            <a:srgbClr val="E1D8DE"/>
+          </a:solidFill>
+          <a:ln>
+            <a:noFill/>
+          </a:ln>
+          <a:effectLst/>
+        </p:spPr>
+        <p:style>
+          <a:lnRef idx="1">
+            <a:schemeClr val="accent1"/>
+          </a:lnRef>
+          <a:fillRef idx="3">
+            <a:schemeClr val="accent1"/>
+          </a:fillRef>
+          <a:effectRef idx="2">
+            <a:schemeClr val="accent1"/>
+          </a:effectRef>
+          <a:fontRef idx="minor">
+            <a:schemeClr val="lt1"/>
+          </a:fontRef>
+        </p:style>
+        <p:txBody>
+          <a:bodyPr rtlCol="0" anchor="ctr"/>
+          <a:lstStyle/>
+          <a:p>
+            <a:pPr algn="ctr"/>
+          </a:p>
+        </p:txBody>
+      </p:sp>
+      <p:sp>
+        <p:nvSpPr>
+          <p:cNvPr id="6" name="TextBox 5"/>
           <p:cNvSpPr txBox="1"/>
           <p:nvPr/>
         </p:nvSpPr>
         <p:spPr>
           <a:xfrm>
-            <a:off x="411480" y="914400"/>
-            <a:ext cx="3291840" cy="2743200"/>
+            <a:off x="320040" y="320040"/>
+            <a:ext cx="3108960" cy="457200"/>
           </a:xfrm>
           <a:prstGeom prst="rect">
             <a:avLst/>
@@ -40537,9 +42218,48 @@
               </a:lnSpc>
             </a:pPr>
             <a:r>
-              <a:rPr sz="18000" b="1">
-                <a:solidFill>
-                  <a:srgbClr val="F2B27A"/>
+              <a:rPr sz="2800" b="1">
+                <a:solidFill>
+                  <a:srgbClr val="FFFFFF"/>
+                </a:solidFill>
+                <a:latin typeface="Arial"/>
+              </a:rPr>
+              <a:t>PART</a:t>
+            </a:r>
+          </a:p>
+        </p:txBody>
+      </p:sp>
+      <p:sp>
+        <p:nvSpPr>
+          <p:cNvPr id="7" name="TextBox 6"/>
+          <p:cNvSpPr txBox="1"/>
+          <p:nvPr/>
+        </p:nvSpPr>
+        <p:spPr>
+          <a:xfrm>
+            <a:off x="182880" y="731520"/>
+            <a:ext cx="3383280" cy="3108960"/>
+          </a:xfrm>
+          <a:prstGeom prst="rect">
+            <a:avLst/>
+          </a:prstGeom>
+          <a:noFill/>
+        </p:spPr>
+        <p:txBody>
+          <a:bodyPr wrap="square" anchor="t" lIns="0" rIns="0" tIns="0" bIns="0">
+            <a:spAutoFit/>
+          </a:bodyPr>
+          <a:lstStyle/>
+          <a:p>
+            <a:pPr algn="l">
+              <a:lnSpc>
+                <a:spcPct val="100000"/>
+              </a:lnSpc>
+            </a:pPr>
+            <a:r>
+              <a:rPr sz="22000" b="1">
+                <a:solidFill>
+                  <a:srgbClr val="FFFFFF"/>
                 </a:solidFill>
                 <a:latin typeface="Arial"/>
               </a:rPr>
@@ -40550,14 +42270,14 @@
       </p:sp>
       <p:sp>
         <p:nvSpPr>
-          <p:cNvPr id="3" name="TextBox 2"/>
+          <p:cNvPr id="8" name="TextBox 7"/>
           <p:cNvSpPr txBox="1"/>
           <p:nvPr/>
         </p:nvSpPr>
         <p:spPr>
           <a:xfrm>
-            <a:off x="3840480" y="548640"/>
-            <a:ext cx="7863840" cy="2103120"/>
+            <a:off x="4206240" y="502920"/>
+            <a:ext cx="7589520" cy="2103120"/>
           </a:xfrm>
           <a:prstGeom prst="rect">
             <a:avLst/>
@@ -40589,14 +42309,14 @@
       </p:sp>
       <p:sp>
         <p:nvSpPr>
-          <p:cNvPr id="4" name="TextBox 3"/>
+          <p:cNvPr id="9" name="TextBox 8"/>
           <p:cNvSpPr txBox="1"/>
           <p:nvPr/>
         </p:nvSpPr>
         <p:spPr>
           <a:xfrm>
-            <a:off x="3840480" y="2743200"/>
-            <a:ext cx="7863840" cy="914400"/>
+            <a:off x="4206240" y="2697480"/>
+            <a:ext cx="7589520" cy="914400"/>
           </a:xfrm>
           <a:prstGeom prst="rect">
             <a:avLst/>
@@ -40628,14 +42348,14 @@
       </p:sp>
       <p:sp>
         <p:nvSpPr>
-          <p:cNvPr id="5" name="TextBox 4"/>
+          <p:cNvPr id="10" name="TextBox 9"/>
           <p:cNvSpPr txBox="1"/>
           <p:nvPr/>
         </p:nvSpPr>
         <p:spPr>
           <a:xfrm>
-            <a:off x="3840480" y="3794760"/>
-            <a:ext cx="7863840" cy="1005840"/>
+            <a:off x="4206240" y="3703320"/>
+            <a:ext cx="7589520" cy="1005840"/>
           </a:xfrm>
           <a:prstGeom prst="rect">
             <a:avLst/>
@@ -40667,14 +42387,14 @@
       </p:sp>
       <p:sp>
         <p:nvSpPr>
-          <p:cNvPr id="6" name="EXEMPT_PROGRESS"/>
+          <p:cNvPr id="11" name="EXEMPT_PROGRESS"/>
           <p:cNvSpPr txBox="1"/>
           <p:nvPr/>
         </p:nvSpPr>
         <p:spPr>
           <a:xfrm>
-            <a:off x="3840480" y="5074920"/>
-            <a:ext cx="7863840" cy="457200"/>
+            <a:off x="4206240" y="4983480"/>
+            <a:ext cx="7589520" cy="457200"/>
           </a:xfrm>
           <a:prstGeom prst="rect">
             <a:avLst/>

</xml_diff>

<commit_message>
Divider frames: optional anime stills with credits, built only into gitignored 03_WITH_FRAMES decks
</commit_message>
<xml_diff>
--- a/01_FULL_DECK/ADBS_FULL_answer_key.pptx
+++ b/01_FULL_DECK/ADBS_FULL_answer_key.pptx
@@ -14453,7 +14453,7 @@
         </p:nvSpPr>
         <p:spPr>
           <a:xfrm>
-            <a:off x="4206240" y="502920"/>
+            <a:off x="4206240" y="411480"/>
             <a:ext cx="7589520" cy="2103120"/>
           </a:xfrm>
           <a:prstGeom prst="rect">
@@ -14492,7 +14492,7 @@
         </p:nvSpPr>
         <p:spPr>
           <a:xfrm>
-            <a:off x="4206240" y="2697480"/>
+            <a:off x="4206240" y="2651760"/>
             <a:ext cx="7589520" cy="914400"/>
           </a:xfrm>
           <a:prstGeom prst="rect">
@@ -14531,8 +14531,8 @@
         </p:nvSpPr>
         <p:spPr>
           <a:xfrm>
-            <a:off x="4206240" y="3703320"/>
-            <a:ext cx="7589520" cy="1005840"/>
+            <a:off x="4206240" y="3657600"/>
+            <a:ext cx="7589520" cy="1188720"/>
           </a:xfrm>
           <a:prstGeom prst="rect">
             <a:avLst/>
@@ -14570,7 +14570,7 @@
         </p:nvSpPr>
         <p:spPr>
           <a:xfrm>
-            <a:off x="4206240" y="4983480"/>
+            <a:off x="4206240" y="5074920"/>
             <a:ext cx="7589520" cy="457200"/>
           </a:xfrm>
           <a:prstGeom prst="rect">
@@ -21148,7 +21148,7 @@
         </p:nvSpPr>
         <p:spPr>
           <a:xfrm>
-            <a:off x="4206240" y="502920"/>
+            <a:off x="4206240" y="411480"/>
             <a:ext cx="7589520" cy="2103120"/>
           </a:xfrm>
           <a:prstGeom prst="rect">
@@ -21187,7 +21187,7 @@
         </p:nvSpPr>
         <p:spPr>
           <a:xfrm>
-            <a:off x="4206240" y="2697480"/>
+            <a:off x="4206240" y="2651760"/>
             <a:ext cx="7589520" cy="914400"/>
           </a:xfrm>
           <a:prstGeom prst="rect">
@@ -21226,8 +21226,8 @@
         </p:nvSpPr>
         <p:spPr>
           <a:xfrm>
-            <a:off x="4206240" y="3703320"/>
-            <a:ext cx="7589520" cy="1005840"/>
+            <a:off x="4206240" y="3657600"/>
+            <a:ext cx="7589520" cy="1188720"/>
           </a:xfrm>
           <a:prstGeom prst="rect">
             <a:avLst/>
@@ -21265,7 +21265,7 @@
         </p:nvSpPr>
         <p:spPr>
           <a:xfrm>
-            <a:off x="4206240" y="4983480"/>
+            <a:off x="4206240" y="5074920"/>
             <a:ext cx="7589520" cy="457200"/>
           </a:xfrm>
           <a:prstGeom prst="rect">
@@ -25535,7 +25535,7 @@
         </p:nvSpPr>
         <p:spPr>
           <a:xfrm>
-            <a:off x="4206240" y="502920"/>
+            <a:off x="4206240" y="411480"/>
             <a:ext cx="7589520" cy="2103120"/>
           </a:xfrm>
           <a:prstGeom prst="rect">
@@ -25574,7 +25574,7 @@
         </p:nvSpPr>
         <p:spPr>
           <a:xfrm>
-            <a:off x="4206240" y="2697480"/>
+            <a:off x="4206240" y="2651760"/>
             <a:ext cx="7589520" cy="914400"/>
           </a:xfrm>
           <a:prstGeom prst="rect">
@@ -25613,8 +25613,8 @@
         </p:nvSpPr>
         <p:spPr>
           <a:xfrm>
-            <a:off x="4206240" y="3703320"/>
-            <a:ext cx="7589520" cy="1005840"/>
+            <a:off x="4206240" y="3657600"/>
+            <a:ext cx="7589520" cy="1188720"/>
           </a:xfrm>
           <a:prstGeom prst="rect">
             <a:avLst/>
@@ -25652,7 +25652,7 @@
         </p:nvSpPr>
         <p:spPr>
           <a:xfrm>
-            <a:off x="4206240" y="4983480"/>
+            <a:off x="4206240" y="5074920"/>
             <a:ext cx="7589520" cy="457200"/>
           </a:xfrm>
           <a:prstGeom prst="rect">
@@ -29383,7 +29383,7 @@
         </p:nvSpPr>
         <p:spPr>
           <a:xfrm>
-            <a:off x="4206240" y="502920"/>
+            <a:off x="4206240" y="411480"/>
             <a:ext cx="7589520" cy="2103120"/>
           </a:xfrm>
           <a:prstGeom prst="rect">
@@ -29422,7 +29422,7 @@
         </p:nvSpPr>
         <p:spPr>
           <a:xfrm>
-            <a:off x="4206240" y="2697480"/>
+            <a:off x="4206240" y="2651760"/>
             <a:ext cx="7589520" cy="914400"/>
           </a:xfrm>
           <a:prstGeom prst="rect">
@@ -29461,8 +29461,8 @@
         </p:nvSpPr>
         <p:spPr>
           <a:xfrm>
-            <a:off x="4206240" y="3703320"/>
-            <a:ext cx="7589520" cy="1005840"/>
+            <a:off x="4206240" y="3657600"/>
+            <a:ext cx="7589520" cy="1188720"/>
           </a:xfrm>
           <a:prstGeom prst="rect">
             <a:avLst/>
@@ -29500,7 +29500,7 @@
         </p:nvSpPr>
         <p:spPr>
           <a:xfrm>
-            <a:off x="4206240" y="4983480"/>
+            <a:off x="4206240" y="5074920"/>
             <a:ext cx="7589520" cy="457200"/>
           </a:xfrm>
           <a:prstGeom prst="rect">
@@ -32699,7 +32699,7 @@
         </p:nvSpPr>
         <p:spPr>
           <a:xfrm>
-            <a:off x="4206240" y="502920"/>
+            <a:off x="4206240" y="411480"/>
             <a:ext cx="7589520" cy="2103120"/>
           </a:xfrm>
           <a:prstGeom prst="rect">
@@ -32738,7 +32738,7 @@
         </p:nvSpPr>
         <p:spPr>
           <a:xfrm>
-            <a:off x="4206240" y="2697480"/>
+            <a:off x="4206240" y="2651760"/>
             <a:ext cx="7589520" cy="914400"/>
           </a:xfrm>
           <a:prstGeom prst="rect">
@@ -32777,8 +32777,8 @@
         </p:nvSpPr>
         <p:spPr>
           <a:xfrm>
-            <a:off x="4206240" y="3703320"/>
-            <a:ext cx="7589520" cy="1005840"/>
+            <a:off x="4206240" y="3657600"/>
+            <a:ext cx="7589520" cy="1188720"/>
           </a:xfrm>
           <a:prstGeom prst="rect">
             <a:avLst/>
@@ -32816,7 +32816,7 @@
         </p:nvSpPr>
         <p:spPr>
           <a:xfrm>
-            <a:off x="4206240" y="4983480"/>
+            <a:off x="4206240" y="5074920"/>
             <a:ext cx="7589520" cy="457200"/>
           </a:xfrm>
           <a:prstGeom prst="rect">
@@ -35970,7 +35970,7 @@
         </p:nvSpPr>
         <p:spPr>
           <a:xfrm>
-            <a:off x="4206240" y="502920"/>
+            <a:off x="4206240" y="411480"/>
             <a:ext cx="7589520" cy="2103120"/>
           </a:xfrm>
           <a:prstGeom prst="rect">
@@ -36009,7 +36009,7 @@
         </p:nvSpPr>
         <p:spPr>
           <a:xfrm>
-            <a:off x="4206240" y="2697480"/>
+            <a:off x="4206240" y="2651760"/>
             <a:ext cx="7589520" cy="914400"/>
           </a:xfrm>
           <a:prstGeom prst="rect">
@@ -36048,8 +36048,8 @@
         </p:nvSpPr>
         <p:spPr>
           <a:xfrm>
-            <a:off x="4206240" y="3703320"/>
-            <a:ext cx="7589520" cy="1005840"/>
+            <a:off x="4206240" y="3657600"/>
+            <a:ext cx="7589520" cy="1188720"/>
           </a:xfrm>
           <a:prstGeom prst="rect">
             <a:avLst/>
@@ -36087,7 +36087,7 @@
         </p:nvSpPr>
         <p:spPr>
           <a:xfrm>
-            <a:off x="4206240" y="4983480"/>
+            <a:off x="4206240" y="5074920"/>
             <a:ext cx="7589520" cy="457200"/>
           </a:xfrm>
           <a:prstGeom prst="rect">
@@ -38908,7 +38908,7 @@
         </p:nvSpPr>
         <p:spPr>
           <a:xfrm>
-            <a:off x="4206240" y="502920"/>
+            <a:off x="4206240" y="411480"/>
             <a:ext cx="7589520" cy="2103120"/>
           </a:xfrm>
           <a:prstGeom prst="rect">
@@ -38947,7 +38947,7 @@
         </p:nvSpPr>
         <p:spPr>
           <a:xfrm>
-            <a:off x="4206240" y="2697480"/>
+            <a:off x="4206240" y="2651760"/>
             <a:ext cx="7589520" cy="914400"/>
           </a:xfrm>
           <a:prstGeom prst="rect">
@@ -38986,8 +38986,8 @@
         </p:nvSpPr>
         <p:spPr>
           <a:xfrm>
-            <a:off x="4206240" y="3703320"/>
-            <a:ext cx="7589520" cy="1005840"/>
+            <a:off x="4206240" y="3657600"/>
+            <a:ext cx="7589520" cy="1188720"/>
           </a:xfrm>
           <a:prstGeom prst="rect">
             <a:avLst/>
@@ -39025,7 +39025,7 @@
         </p:nvSpPr>
         <p:spPr>
           <a:xfrm>
-            <a:off x="4206240" y="4983480"/>
+            <a:off x="4206240" y="5074920"/>
             <a:ext cx="7589520" cy="457200"/>
           </a:xfrm>
           <a:prstGeom prst="rect">
@@ -42276,7 +42276,7 @@
         </p:nvSpPr>
         <p:spPr>
           <a:xfrm>
-            <a:off x="4206240" y="502920"/>
+            <a:off x="4206240" y="411480"/>
             <a:ext cx="7589520" cy="2103120"/>
           </a:xfrm>
           <a:prstGeom prst="rect">
@@ -42315,7 +42315,7 @@
         </p:nvSpPr>
         <p:spPr>
           <a:xfrm>
-            <a:off x="4206240" y="2697480"/>
+            <a:off x="4206240" y="2651760"/>
             <a:ext cx="7589520" cy="914400"/>
           </a:xfrm>
           <a:prstGeom prst="rect">
@@ -42354,8 +42354,8 @@
         </p:nvSpPr>
         <p:spPr>
           <a:xfrm>
-            <a:off x="4206240" y="3703320"/>
-            <a:ext cx="7589520" cy="1005840"/>
+            <a:off x="4206240" y="3657600"/>
+            <a:ext cx="7589520" cy="1188720"/>
           </a:xfrm>
           <a:prstGeom prst="rect">
             <a:avLst/>
@@ -42393,7 +42393,7 @@
         </p:nvSpPr>
         <p:spPr>
           <a:xfrm>
-            <a:off x="4206240" y="4983480"/>
+            <a:off x="4206240" y="5074920"/>
             <a:ext cx="7589520" cy="457200"/>
           </a:xfrm>
           <a:prstGeom prst="rect">

</xml_diff>